<commit_message>
feat(ev3): observaciones del docente — tests de estado de fruta, rendimiento y actas
- test_inference.py: 21 pruebas de verificación del ESTADO DE MADUREZ (prioridad)
  (clase -> fruta/estado/color/recomendación; umbral; filtro). Backend ahora 38 tests.
- medir_rendimiento.py + 09_Pruebas_Rendimiento.md: tiempos de respuesta y carga
  con usuarios concurrentes en ambiente controlado (0 errores hasta 50 concurrentes).
- 3 actas de avance (EP1/EP2/EP3) en PDF, con datos, entregables y doble firma.
- actualizar conteo a 57 pruebas (38+19) en plan, informe, guiones, PPT y reporte HTML.
</commit_message>
<xml_diff>
--- a/Documentación/Evaluacion_3/MaduraApp_Presentacion_Evaluacion3.pptx
+++ b/Documentación/Evaluacion_3/MaduraApp_Presentacion_Evaluacion3.pptx
@@ -790,7 +790,7 @@
           <a:lstStyle/>
           <a:p>
             <a:r>
-              <a:t>Apliqué el plan y este es el resultado: 36 de 36 pruebas en verde, ejecutadas hoy. El backend con pytest, el Android con MockK y JUnit. Además agregué integración continua: un workflow que corre la suite en cada push, así ningún cambio rompe las pruebas sin que nos enteremos. En calidad: el modelo cumple el KPI con 0.92, pesa 5.2 MB y el APK compila. Si preguntan qué detecta cada test: los de validación verifican los caminos felices y de error de cada endpoint; los de Android, que el cache offline y los estados de la UI sean correctos. Demostrar dominio: puedo abrir el reporte si lo piden.</a:t>
+              <a:t>Apliqué el plan y este es el resultado: 57 de 57 pruebas en verde, ejecutadas hoy. El backend con pytest, el Android con MockK y JUnit. Además agregué integración continua: un workflow que corre la suite en cada push, así ningún cambio rompe las pruebas sin que nos enteremos. En calidad: el modelo cumple el KPI con 0.92, pesa 5.2 MB y el APK compila. Si preguntan qué detecta cada test: los de validación verifican los caminos felices y de error de cada endpoint; los de Android, que el cache offline y los estados de la UI sean correctos. Demostrar dominio: puedo abrir el reporte si lo piden.</a:t>
             </a:r>
           </a:p>
         </p:txBody>
@@ -1000,7 +1000,7 @@
           <a:lstStyle/>
           <a:p>
             <a:r>
-              <a:t>Para cerrar: MaduraApp es un producto funcional, probado y seguro. 36 de 36 pruebas en verde, 15 mejoras trazables a los estándares de calidad, y datos personales protegidos. Soy honesto con lo que falta: desplegar el backend en el laboratorio AWS, automatizar las pruebas end-to-end, y obtener su aprobación del plan en esta defensa. Gracias, quedo atento a sus preguntas. Cerrar con seguridad y agradecer.</a:t>
+              <a:t>Para cerrar: MaduraApp es un producto funcional, probado y seguro. 57 de 57 pruebas en verde, 15 mejoras trazables a los estándares de calidad, y datos personales protegidos. Soy honesto con lo que falta: desplegar el backend en el laboratorio AWS, automatizar las pruebas end-to-end, y obtener su aprobación del plan en esta defensa. Gracias, quedo atento a sus preguntas. Cerrar con seguridad y agradecer.</a:t>
             </a:r>
           </a:p>
         </p:txBody>
@@ -5216,7 +5216,7 @@
                 </a:solidFill>
                 <a:latin typeface="Calibri"/>
               </a:rPr>
-              <a:t>• 36 casos automatizados (17 backend + 19 Android)</a:t>
+              <a:t>• 57 casos automatizados (38 backend + 19 Android)</a:t>
             </a:r>
           </a:p>
           <a:p>
@@ -5336,11 +5336,11 @@
                 <a:tableStyleId>{5C22544A-7EE6-4342-B048-85BDC9FD1C3A}</a:tableStyleId>
               </a:tblPr>
               <a:tblGrid>
-                <a:gridCol w="2651760"/>
-                <a:gridCol w="1280160"/>
-                <a:gridCol w="1280160"/>
+                <a:gridCol w="2834640"/>
+                <a:gridCol w="1188720"/>
+                <a:gridCol w="1188720"/>
               </a:tblGrid>
-              <a:tr h="457200">
+              <a:tr h="571500">
                 <a:tc>
                   <a:txBody>
                     <a:bodyPr/>
@@ -5408,7 +5408,7 @@
                   </a:tcPr>
                 </a:tc>
               </a:tr>
-              <a:tr h="457200">
+              <a:tr h="571500">
                 <a:tc>
                   <a:txBody>
                     <a:bodyPr/>
@@ -5420,7 +5420,7 @@
                             <a:srgbClr val="1A1C19"/>
                           </a:solidFill>
                         </a:rPr>
-                        <a:t>Validación backend</a:t>
+                        <a:t>Estado de fruta (backend)</a:t>
                       </a:r>
                     </a:p>
                   </a:txBody>
@@ -5441,7 +5441,7 @@
                             <a:srgbClr val="1A1C19"/>
                           </a:solidFill>
                         </a:rPr>
-                        <a:t>15</a:t>
+                        <a:t>21</a:t>
                       </a:r>
                     </a:p>
                   </a:txBody>
@@ -5473,7 +5473,7 @@
                   </a:tcPr>
                 </a:tc>
               </a:tr>
-              <a:tr h="457200">
+              <a:tr h="571500">
                 <a:tc>
                   <a:txBody>
                     <a:bodyPr/>
@@ -5485,7 +5485,7 @@
                             <a:srgbClr val="1A1C19"/>
                           </a:solidFill>
                         </a:rPr>
-                        <a:t>Seguridad (OWASP)</a:t>
+                        <a:t>Validación backend</a:t>
                       </a:r>
                     </a:p>
                   </a:txBody>
@@ -5506,7 +5506,7 @@
                             <a:srgbClr val="1A1C19"/>
                           </a:solidFill>
                         </a:rPr>
-                        <a:t>3</a:t>
+                        <a:t>17</a:t>
                       </a:r>
                     </a:p>
                   </a:txBody>
@@ -5538,7 +5538,7 @@
                   </a:tcPr>
                 </a:tc>
               </a:tr>
-              <a:tr h="457200">
+              <a:tr h="571500">
                 <a:tc>
                   <a:txBody>
                     <a:bodyPr/>
@@ -5599,71 +5599,6 @@
                   <a:tcPr>
                     <a:solidFill>
                       <a:srgbClr val="FFFFFF"/>
-                    </a:solidFill>
-                  </a:tcPr>
-                </a:tc>
-              </a:tr>
-              <a:tr h="457200">
-                <a:tc>
-                  <a:txBody>
-                    <a:bodyPr/>
-                    <a:lstStyle/>
-                    <a:p>
-                      <a:r>
-                        <a:rPr sz="1200">
-                          <a:solidFill>
-                            <a:srgbClr val="1A1C19"/>
-                          </a:solidFill>
-                        </a:rPr>
-                        <a:t>Verificación</a:t>
-                      </a:r>
-                    </a:p>
-                  </a:txBody>
-                  <a:tcPr>
-                    <a:solidFill>
-                      <a:srgbClr val="F0F4EE"/>
-                    </a:solidFill>
-                  </a:tcPr>
-                </a:tc>
-                <a:tc>
-                  <a:txBody>
-                    <a:bodyPr/>
-                    <a:lstStyle/>
-                    <a:p>
-                      <a:r>
-                        <a:rPr sz="1200">
-                          <a:solidFill>
-                            <a:srgbClr val="1A1C19"/>
-                          </a:solidFill>
-                        </a:rPr>
-                        <a:t>6</a:t>
-                      </a:r>
-                    </a:p>
-                  </a:txBody>
-                  <a:tcPr>
-                    <a:solidFill>
-                      <a:srgbClr val="F0F4EE"/>
-                    </a:solidFill>
-                  </a:tcPr>
-                </a:tc>
-                <a:tc>
-                  <a:txBody>
-                    <a:bodyPr/>
-                    <a:lstStyle/>
-                    <a:p>
-                      <a:r>
-                        <a:rPr sz="1200">
-                          <a:solidFill>
-                            <a:srgbClr val="1A1C19"/>
-                          </a:solidFill>
-                        </a:rPr>
-                        <a:t>✅</a:t>
-                      </a:r>
-                    </a:p>
-                  </a:txBody>
-                  <a:tcPr>
-                    <a:solidFill>
-                      <a:srgbClr val="F0F4EE"/>
                     </a:solidFill>
                   </a:tcPr>
                 </a:tc>
@@ -6051,7 +5986,7 @@
                             <a:srgbClr val="1A1C19"/>
                           </a:solidFill>
                         </a:rPr>
-                        <a:t>17</a:t>
+                        <a:t>38</a:t>
                       </a:r>
                     </a:p>
                   </a:txBody>
@@ -6072,7 +6007,7 @@
                             <a:srgbClr val="1A1C19"/>
                           </a:solidFill>
                         </a:rPr>
-                        <a:t>✅ 17/17</a:t>
+                        <a:t>✅ 38/38</a:t>
                       </a:r>
                     </a:p>
                   </a:txBody>
@@ -6309,7 +6244,7 @@
                             <a:srgbClr val="1A1C19"/>
                           </a:solidFill>
                         </a:rPr>
-                        <a:t>36</a:t>
+                        <a:t>57</a:t>
                       </a:r>
                     </a:p>
                   </a:txBody>
@@ -6330,7 +6265,7 @@
                             <a:srgbClr val="1A1C19"/>
                           </a:solidFill>
                         </a:rPr>
-                        <a:t>✅ 36/36</a:t>
+                        <a:t>✅ 57/57</a:t>
                       </a:r>
                     </a:p>
                   </a:txBody>
@@ -6373,13 +6308,29 @@
               </a:spcAft>
             </a:pPr>
             <a:r>
-              <a:rPr sz="1700">
+              <a:rPr sz="1600">
                 <a:solidFill>
                   <a:srgbClr val="1A1C19"/>
                 </a:solidFill>
                 <a:latin typeface="Calibri"/>
               </a:rPr>
-              <a:t>• 36/36 en verde (21/06/2026)</a:t>
+              <a:t>• 57/57 en verde</a:t>
+            </a:r>
+          </a:p>
+          <a:p>
+            <a:pPr lvl="1">
+              <a:spcAft>
+                <a:spcPts val="600"/>
+              </a:spcAft>
+            </a:pPr>
+            <a:r>
+              <a:rPr sz="1400">
+                <a:solidFill>
+                  <a:srgbClr val="1A1C19"/>
+                </a:solidFill>
+                <a:latin typeface="Calibri"/>
+              </a:rPr>
+              <a:t>– 21 verifican estado de fruta</a:t>
             </a:r>
           </a:p>
           <a:p>
@@ -6389,7 +6340,7 @@
               </a:spcAft>
             </a:pPr>
             <a:r>
-              <a:rPr sz="1700">
+              <a:rPr sz="1600">
                 <a:solidFill>
                   <a:srgbClr val="1A1C19"/>
                 </a:solidFill>
@@ -6405,13 +6356,13 @@
               </a:spcAft>
             </a:pPr>
             <a:r>
-              <a:rPr sz="1700">
+              <a:rPr sz="1600">
                 <a:solidFill>
                   <a:srgbClr val="1A1C19"/>
                 </a:solidFill>
                 <a:latin typeface="Calibri"/>
               </a:rPr>
-              <a:t>• Calidad verificada:</a:t>
+              <a:t>• Rendimiento: ~200 ms inferencia</a:t>
             </a:r>
           </a:p>
           <a:p>
@@ -6421,45 +6372,29 @@
               </a:spcAft>
             </a:pPr>
             <a:r>
-              <a:rPr sz="1500">
+              <a:rPr sz="1400">
                 <a:solidFill>
                   <a:srgbClr val="1A1C19"/>
                 </a:solidFill>
                 <a:latin typeface="Calibri"/>
               </a:rPr>
-              <a:t>– mAP@50 = 0.9229</a:t>
-            </a:r>
-          </a:p>
-          <a:p>
-            <a:pPr lvl="1">
+              <a:t>– 0 errores hasta 50 concurrentes</a:t>
+            </a:r>
+          </a:p>
+          <a:p>
+            <a:pPr>
               <a:spcAft>
                 <a:spcPts val="600"/>
               </a:spcAft>
             </a:pPr>
             <a:r>
-              <a:rPr sz="1500">
+              <a:rPr sz="1600">
                 <a:solidFill>
                   <a:srgbClr val="1A1C19"/>
                 </a:solidFill>
                 <a:latin typeface="Calibri"/>
               </a:rPr>
-              <a:t>– modelo 5.2 MB</a:t>
-            </a:r>
-          </a:p>
-          <a:p>
-            <a:pPr lvl="1">
-              <a:spcAft>
-                <a:spcPts val="600"/>
-              </a:spcAft>
-            </a:pPr>
-            <a:r>
-              <a:rPr sz="1500">
-                <a:solidFill>
-                  <a:srgbClr val="1A1C19"/>
-                </a:solidFill>
-                <a:latin typeface="Calibri"/>
-              </a:rPr>
-              <a:t>– APK compila, migraciones OK</a:t>
+              <a:t>• mAP@50 = 0.9229 · 5.2 MB</a:t>
             </a:r>
           </a:p>
         </p:txBody>
@@ -7533,7 +7468,7 @@
                 </a:solidFill>
                 <a:latin typeface="Calibri"/>
               </a:rPr>
-              <a:t>– 36/36 pruebas en verde en todos los componentes</a:t>
+              <a:t>– 57/57 pruebas en verde en todos los componentes</a:t>
             </a:r>
           </a:p>
           <a:p>
@@ -7708,7 +7643,7 @@
                 </a:solidFill>
                 <a:latin typeface="Calibri"/>
               </a:rPr>
-              <a:t>36/36
+              <a:t>57/57
 pruebas en verde
 mAP@50 = 0.9229
 15 mejoras

</xml_diff>